<commit_message>
Add final render to submission deck
</commit_message>
<xml_diff>
--- a/presentation/HSL_Technical_Assessment_3DGS_Composition.pptx
+++ b/presentation/HSL_Technical_Assessment_3DGS_Composition.pptx
@@ -5508,7 +5508,7 @@
                 </a:solidFill>
                 <a:latin typeface="Aptos Display"/>
               </a:rPr>
-              <a:t>What I Would Defend</a:t>
+              <a:t>Result &amp; Defense</a:t>
             </a:r>
           </a:p>
         </p:txBody>
@@ -5522,7 +5522,7 @@
         <p:spPr>
           <a:xfrm>
             <a:off x="711182" y="952500"/>
-            <a:ext cx="7048323" cy="355600"/>
+            <a:ext cx="8000799" cy="355600"/>
           </a:xfrm>
           <a:prstGeom prst="rect">
             <a:avLst/>
@@ -5543,56 +5543,125 @@
                 </a:solidFill>
                 <a:latin typeface="Aptos"/>
               </a:rPr>
-              <a:t>The hard part is not only training splats. It is choosing a defensible cross-dataset similarity transform.</a:t>
-            </a:r>
-          </a:p>
-        </p:txBody>
-      </p:sp>
-      <p:cxnSp>
-        <p:nvCxnSpPr>
-          <p:cNvPr id="5" name="Connector 4"/>
-          <p:cNvCxnSpPr/>
-          <p:nvPr/>
-        </p:nvCxnSpPr>
-        <p:spPr>
-          <a:xfrm>
-            <a:off x="749281" y="1873250"/>
-            <a:ext cx="0" cy="3587750"/>
-          </a:xfrm>
-          <a:prstGeom prst="line">
-            <a:avLst/>
-          </a:prstGeom>
-          <a:ln w="38100">
+              <a:t>The output is not a 2D paste. It is one merged 3DGS point cloud rendered through the Bicycle cameras.</a:t>
+            </a:r>
+          </a:p>
+        </p:txBody>
+      </p:sp>
+      <p:pic>
+        <p:nvPicPr>
+          <p:cNvPr id="5" name="Picture 4" descr="hsl_final_result.png"/>
+          <p:cNvPicPr>
+            <a:picLocks noChangeAspect="1"/>
+          </p:cNvPicPr>
+          <p:nvPr/>
+        </p:nvPicPr>
+        <p:blipFill>
+          <a:blip r:embed="rId2"/>
+          <a:stretch>
+            <a:fillRect/>
+          </a:stretch>
+        </p:blipFill>
+        <p:spPr>
+          <a:xfrm>
+            <a:off x="698482" y="1592123"/>
+            <a:ext cx="5714857" cy="3800752"/>
+          </a:xfrm>
+          <a:prstGeom prst="rect">
+            <a:avLst/>
+          </a:prstGeom>
+        </p:spPr>
+      </p:pic>
+      <p:sp>
+        <p:nvSpPr>
+          <p:cNvPr id="6" name="Rectangle 5"/>
+          <p:cNvSpPr/>
+          <p:nvPr/>
+        </p:nvSpPr>
+        <p:spPr>
+          <a:xfrm>
+            <a:off x="698482" y="1587500"/>
+            <a:ext cx="5714857" cy="3810000"/>
+          </a:xfrm>
+          <a:prstGeom prst="rect">
+            <a:avLst/>
+          </a:prstGeom>
+          <a:solidFill>
+            <a:srgbClr val="FFFFFF"/>
+          </a:solidFill>
+          <a:ln w="12700">
             <a:solidFill>
               <a:srgbClr val="C8C2B4"/>
             </a:solidFill>
           </a:ln>
         </p:spPr>
         <p:style>
-          <a:lnRef idx="2">
+          <a:lnRef idx="1">
             <a:schemeClr val="accent1"/>
           </a:lnRef>
-          <a:fillRef idx="0">
+          <a:fillRef idx="3">
             <a:schemeClr val="accent1"/>
           </a:fillRef>
-          <a:effectRef idx="1">
+          <a:effectRef idx="2">
             <a:schemeClr val="accent1"/>
           </a:effectRef>
           <a:fontRef idx="minor">
-            <a:schemeClr val="tx1"/>
+            <a:schemeClr val="lt1"/>
           </a:fontRef>
         </p:style>
-      </p:cxnSp>
-      <p:sp>
-        <p:nvSpPr>
-          <p:cNvPr id="6" name="Oval 5"/>
+        <p:txBody>
+          <a:bodyPr rtlCol="0" anchor="ctr"/>
+          <a:lstStyle/>
+          <a:p>
+            <a:pPr algn="ctr"/>
+          </a:p>
+        </p:txBody>
+      </p:sp>
+      <p:sp>
+        <p:nvSpPr>
+          <p:cNvPr id="7" name="TextBox 6"/>
+          <p:cNvSpPr txBox="1"/>
+          <p:nvPr/>
+        </p:nvSpPr>
+        <p:spPr>
+          <a:xfrm>
+            <a:off x="698482" y="5537200"/>
+            <a:ext cx="2349441" cy="241300"/>
+          </a:xfrm>
+          <a:prstGeom prst="rect">
+            <a:avLst/>
+          </a:prstGeom>
+          <a:noFill/>
+        </p:spPr>
+        <p:txBody>
+          <a:bodyPr wrap="square" lIns="0" rIns="0" tIns="0" bIns="0">
+            <a:spAutoFit/>
+          </a:bodyPr>
+          <a:lstStyle/>
+          <a:p>
+            <a:pPr algn="l"/>
+            <a:r>
+              <a:rPr sz="1900" b="1">
+                <a:solidFill>
+                  <a:srgbClr val="1F766F"/>
+                </a:solidFill>
+                <a:latin typeface="Aptos"/>
+              </a:rPr>
+              <a:t>final composed render</a:t>
+            </a:r>
+          </a:p>
+        </p:txBody>
+      </p:sp>
+      <p:sp>
+        <p:nvSpPr>
+          <p:cNvPr id="8" name="Oval 7"/>
           <p:cNvSpPr/>
           <p:nvPr/>
         </p:nvSpPr>
         <p:spPr>
           <a:xfrm>
-            <a:off x="584185" y="1657350"/>
-            <a:ext cx="330191" cy="330200"/>
+            <a:off x="6807029" y="1676400"/>
+            <a:ext cx="292092" cy="292100"/>
           </a:xfrm>
           <a:prstGeom prst="ellipse">
             <a:avLst/>
@@ -5628,14 +5697,14 @@
       </p:sp>
       <p:sp>
         <p:nvSpPr>
-          <p:cNvPr id="7" name="TextBox 6"/>
+          <p:cNvPr id="9" name="TextBox 8"/>
           <p:cNvSpPr txBox="1"/>
           <p:nvPr/>
         </p:nvSpPr>
         <p:spPr>
           <a:xfrm>
-            <a:off x="1092172" y="1600200"/>
-            <a:ext cx="2984425" cy="266700"/>
+            <a:off x="7264218" y="1612900"/>
+            <a:ext cx="2920926" cy="266700"/>
           </a:xfrm>
           <a:prstGeom prst="rect">
             <a:avLst/>
@@ -5656,21 +5725,21 @@
                 </a:solidFill>
                 <a:latin typeface="Aptos"/>
               </a:rPr>
-              <a:t>Scale ambiguity</a:t>
-            </a:r>
-          </a:p>
-        </p:txBody>
-      </p:sp>
-      <p:sp>
-        <p:nvSpPr>
-          <p:cNvPr id="8" name="TextBox 7"/>
+              <a:t>Result</a:t>
+            </a:r>
+          </a:p>
+        </p:txBody>
+      </p:sp>
+      <p:sp>
+        <p:nvSpPr>
+          <p:cNvPr id="10" name="TextBox 9"/>
           <p:cNvSpPr txBox="1"/>
           <p:nvPr/>
         </p:nvSpPr>
         <p:spPr>
           <a:xfrm>
-            <a:off x="4127396" y="1600200"/>
-            <a:ext cx="6032349" cy="406400"/>
+            <a:off x="7264218" y="1943100"/>
+            <a:ext cx="3936901" cy="584200"/>
           </a:xfrm>
           <a:prstGeom prst="rect">
             <a:avLst/>
@@ -5685,39 +5754,39 @@
           <a:p>
             <a:pPr algn="l"/>
             <a:r>
-              <a:rPr sz="2400" b="0">
+              <a:rPr sz="2300" b="0">
                 <a:solidFill>
                   <a:srgbClr val="5F6B73"/>
                 </a:solidFill>
                 <a:latin typeface="Aptos"/>
               </a:rPr>
-              <a:t>COLMAP and Blender cameras are internally calibrated,</a:t>
+              <a:t>Separate Bicycle and Chair 3DGS models</a:t>
             </a:r>
           </a:p>
           <a:p>
             <a:pPr algn="l"/>
             <a:r>
-              <a:rPr sz="2400" b="0">
+              <a:rPr sz="2300" b="0">
                 <a:solidFill>
                   <a:srgbClr val="5F6B73"/>
                 </a:solidFill>
                 <a:latin typeface="Aptos"/>
               </a:rPr>
-              <a:t>but Bicycle and Chair do not share a metric ruler.</a:t>
-            </a:r>
-          </a:p>
-        </p:txBody>
-      </p:sp>
-      <p:sp>
-        <p:nvSpPr>
-          <p:cNvPr id="9" name="Oval 8"/>
+              <a:t>merged into one splat point cloud.</a:t>
+            </a:r>
+          </a:p>
+        </p:txBody>
+      </p:sp>
+      <p:sp>
+        <p:nvSpPr>
+          <p:cNvPr id="11" name="Oval 10"/>
           <p:cNvSpPr/>
           <p:nvPr/>
         </p:nvSpPr>
         <p:spPr>
           <a:xfrm>
-            <a:off x="584185" y="2832100"/>
-            <a:ext cx="330191" cy="330200"/>
+            <a:off x="6807029" y="2705099"/>
+            <a:ext cx="292092" cy="292100"/>
           </a:xfrm>
           <a:prstGeom prst="ellipse">
             <a:avLst/>
@@ -5753,14 +5822,14 @@
       </p:sp>
       <p:sp>
         <p:nvSpPr>
-          <p:cNvPr id="10" name="TextBox 9"/>
+          <p:cNvPr id="12" name="TextBox 11"/>
           <p:cNvSpPr txBox="1"/>
           <p:nvPr/>
         </p:nvSpPr>
         <p:spPr>
           <a:xfrm>
-            <a:off x="1092172" y="2774950"/>
-            <a:ext cx="2984425" cy="266700"/>
+            <a:off x="7264218" y="2641600"/>
+            <a:ext cx="2920926" cy="266700"/>
           </a:xfrm>
           <a:prstGeom prst="rect">
             <a:avLst/>
@@ -5781,21 +5850,21 @@
                 </a:solidFill>
                 <a:latin typeface="Aptos"/>
               </a:rPr>
-              <a:t>Practical baseline</a:t>
-            </a:r>
-          </a:p>
-        </p:txBody>
-      </p:sp>
-      <p:sp>
-        <p:nvSpPr>
-          <p:cNvPr id="11" name="TextBox 10"/>
+              <a:t>Scale reasoning</a:t>
+            </a:r>
+          </a:p>
+        </p:txBody>
+      </p:sp>
+      <p:sp>
+        <p:nvSpPr>
+          <p:cNvPr id="13" name="TextBox 12"/>
           <p:cNvSpPr txBox="1"/>
           <p:nvPr/>
         </p:nvSpPr>
         <p:spPr>
           <a:xfrm>
-            <a:off x="4127396" y="2774950"/>
-            <a:ext cx="6032349" cy="406400"/>
+            <a:off x="7264218" y="2971800"/>
+            <a:ext cx="3936901" cy="584200"/>
           </a:xfrm>
           <a:prstGeom prst="rect">
             <a:avLst/>
@@ -5810,39 +5879,39 @@
           <a:p>
             <a:pPr algn="l"/>
             <a:r>
-              <a:rPr sz="2400" b="0">
+              <a:rPr sz="2300" b="0">
                 <a:solidFill>
                   <a:srgbClr val="5F6B73"/>
                 </a:solidFill>
                 <a:latin typeface="Aptos"/>
               </a:rPr>
-              <a:t>Use bounds, visual anchors, and an interactive placement loop;</a:t>
+              <a:t>Cross-dataset scale is ambiguous;</a:t>
             </a:r>
           </a:p>
           <a:p>
             <a:pPr algn="l"/>
             <a:r>
-              <a:rPr sz="2400" b="0">
+              <a:rPr sz="2300" b="0">
                 <a:solidFill>
                   <a:srgbClr val="5F6B73"/>
                 </a:solidFill>
                 <a:latin typeface="Aptos"/>
               </a:rPr>
-              <a:t>keep every value in the JSON config.</a:t>
-            </a:r>
-          </a:p>
-        </p:txBody>
-      </p:sp>
-      <p:sp>
-        <p:nvSpPr>
-          <p:cNvPr id="12" name="Oval 11"/>
+              <a:t>bounds and visual anchors define s, R, t.</a:t>
+            </a:r>
+          </a:p>
+        </p:txBody>
+      </p:sp>
+      <p:sp>
+        <p:nvSpPr>
+          <p:cNvPr id="14" name="Oval 13"/>
           <p:cNvSpPr/>
           <p:nvPr/>
         </p:nvSpPr>
         <p:spPr>
           <a:xfrm>
-            <a:off x="584185" y="4006850"/>
-            <a:ext cx="330191" cy="330200"/>
+            <a:off x="6807029" y="3733799"/>
+            <a:ext cx="292092" cy="292100"/>
           </a:xfrm>
           <a:prstGeom prst="ellipse">
             <a:avLst/>
@@ -5878,14 +5947,14 @@
       </p:sp>
       <p:sp>
         <p:nvSpPr>
-          <p:cNvPr id="13" name="TextBox 12"/>
+          <p:cNvPr id="15" name="TextBox 14"/>
           <p:cNvSpPr txBox="1"/>
           <p:nvPr/>
         </p:nvSpPr>
         <p:spPr>
           <a:xfrm>
-            <a:off x="1092172" y="3949700"/>
-            <a:ext cx="2984425" cy="266700"/>
+            <a:off x="7264218" y="3670300"/>
+            <a:ext cx="2920926" cy="266700"/>
           </a:xfrm>
           <a:prstGeom prst="rect">
             <a:avLst/>
@@ -5906,21 +5975,21 @@
                 </a:solidFill>
                 <a:latin typeface="Aptos"/>
               </a:rPr>
-              <a:t>Likely bottlenecks</a:t>
-            </a:r>
-          </a:p>
-        </p:txBody>
-      </p:sp>
-      <p:sp>
-        <p:nvSpPr>
-          <p:cNvPr id="14" name="TextBox 13"/>
+              <a:t>Conflicts</a:t>
+            </a:r>
+          </a:p>
+        </p:txBody>
+      </p:sp>
+      <p:sp>
+        <p:nvSpPr>
+          <p:cNvPr id="16" name="TextBox 15"/>
           <p:cNvSpPr txBox="1"/>
           <p:nvPr/>
         </p:nvSpPr>
         <p:spPr>
           <a:xfrm>
-            <a:off x="4127396" y="3949700"/>
-            <a:ext cx="6032349" cy="406400"/>
+            <a:off x="7264218" y="4000500"/>
+            <a:ext cx="3936901" cy="584200"/>
           </a:xfrm>
           <a:prstGeom prst="rect">
             <a:avLst/>
@@ -5935,39 +6004,39 @@
           <a:p>
             <a:pPr algn="l"/>
             <a:r>
-              <a:rPr sz="2400" b="0">
+              <a:rPr sz="2300" b="0">
                 <a:solidFill>
                   <a:srgbClr val="5F6B73"/>
                 </a:solidFill>
                 <a:latin typeface="Aptos"/>
               </a:rPr>
-              <a:t>CUDA setup, floaters, splat intersections, and color mismatch</a:t>
+              <a:t>One rasterizer pass gives depth sorting;</a:t>
             </a:r>
           </a:p>
           <a:p>
             <a:pPr algn="l"/>
             <a:r>
-              <a:rPr sz="2400" b="0">
+              <a:rPr sz="2300" b="0">
                 <a:solidFill>
                   <a:srgbClr val="5F6B73"/>
                 </a:solidFill>
                 <a:latin typeface="Aptos"/>
               </a:rPr>
-              <a:t>between real outdoor imagery and synthetic lighting.</a:t>
-            </a:r>
-          </a:p>
-        </p:txBody>
-      </p:sp>
-      <p:sp>
-        <p:nvSpPr>
-          <p:cNvPr id="15" name="Oval 14"/>
+              <a:t>floaters and soft splats remain visible.</a:t>
+            </a:r>
+          </a:p>
+        </p:txBody>
+      </p:sp>
+      <p:sp>
+        <p:nvSpPr>
+          <p:cNvPr id="17" name="Oval 16"/>
           <p:cNvSpPr/>
           <p:nvPr/>
         </p:nvSpPr>
         <p:spPr>
           <a:xfrm>
-            <a:off x="584185" y="5181599"/>
-            <a:ext cx="330191" cy="330200"/>
+            <a:off x="6807029" y="4762500"/>
+            <a:ext cx="292092" cy="292100"/>
           </a:xfrm>
           <a:prstGeom prst="ellipse">
             <a:avLst/>
@@ -6003,14 +6072,14 @@
       </p:sp>
       <p:sp>
         <p:nvSpPr>
-          <p:cNvPr id="16" name="TextBox 15"/>
+          <p:cNvPr id="18" name="TextBox 17"/>
           <p:cNvSpPr txBox="1"/>
           <p:nvPr/>
         </p:nvSpPr>
         <p:spPr>
           <a:xfrm>
-            <a:off x="1092172" y="5124450"/>
-            <a:ext cx="2984425" cy="266700"/>
+            <a:off x="7264218" y="4699000"/>
+            <a:ext cx="2920926" cy="266700"/>
           </a:xfrm>
           <a:prstGeom prst="rect">
             <a:avLst/>
@@ -6038,14 +6107,14 @@
       </p:sp>
       <p:sp>
         <p:nvSpPr>
-          <p:cNvPr id="17" name="TextBox 16"/>
+          <p:cNvPr id="19" name="TextBox 18"/>
           <p:cNvSpPr txBox="1"/>
           <p:nvPr/>
         </p:nvSpPr>
         <p:spPr>
           <a:xfrm>
-            <a:off x="4127396" y="5124450"/>
-            <a:ext cx="6032349" cy="406400"/>
+            <a:off x="7264218" y="5029200"/>
+            <a:ext cx="3936901" cy="584200"/>
           </a:xfrm>
           <a:prstGeom prst="rect">
             <a:avLst/>
@@ -6060,27 +6129,39 @@
           <a:p>
             <a:pPr algn="l"/>
             <a:r>
-              <a:rPr sz="2400" b="0">
+              <a:rPr sz="2300" b="0">
                 <a:solidFill>
                   <a:srgbClr val="5F6B73"/>
                 </a:solidFill>
                 <a:latin typeface="Aptos"/>
               </a:rPr>
-              <a:t>Optimize a small asset-only SH/exposure correction while keeping geometry fixed.</a:t>
-            </a:r>
-          </a:p>
-        </p:txBody>
-      </p:sp>
-      <p:sp>
-        <p:nvSpPr>
-          <p:cNvPr id="18" name="TextBox 17"/>
+              <a:t>Optimize asset-only SH/exposure</a:t>
+            </a:r>
+          </a:p>
+          <a:p>
+            <a:pPr algn="l"/>
+            <a:r>
+              <a:rPr sz="2300" b="0">
+                <a:solidFill>
+                  <a:srgbClr val="5F6B73"/>
+                </a:solidFill>
+                <a:latin typeface="Aptos"/>
+              </a:rPr>
+              <a:t>while keeping geometry fixed.</a:t>
+            </a:r>
+          </a:p>
+        </p:txBody>
+      </p:sp>
+      <p:sp>
+        <p:nvSpPr>
+          <p:cNvPr id="20" name="TextBox 19"/>
           <p:cNvSpPr txBox="1"/>
           <p:nvPr/>
         </p:nvSpPr>
         <p:spPr>
           <a:xfrm>
             <a:off x="698482" y="6095999"/>
-            <a:ext cx="8254793" cy="215899"/>
+            <a:ext cx="9270768" cy="215899"/>
           </a:xfrm>
           <a:prstGeom prst="rect">
             <a:avLst/>
@@ -6101,7 +6182,7 @@
                 </a:solidFill>
                 <a:latin typeface="Aptos"/>
               </a:rPr>
-              <a:t>Submission assets: scripts, composer, placement UI, process notes, and this 3-slide deck.</a:t>
+              <a:t>Submission assets: code, process notes, Kaggle/Colab runners, final render, and this 3-slide deck.</a:t>
             </a:r>
           </a:p>
         </p:txBody>

</xml_diff>